<commit_message>
refactor(report): remove rule fallback path; LLM planner is now sole outline source
- Delete _outline_legacy.py + _kpi_extractor.py (KPIItem moved to _outline.py)
- Inline _convert_item / _infer_role into _outline_planner.py
- Drop REPORT_OUTLINE_PLANNER_ENABLED flag and try/except fallback block
- LLM failures now raise _LLMPlannerFailure instead of silently degrading
- Rewrite baseline harness: stub_planner_llm replaces freeze_kpis;
  regen 4 golden fixtures against frozen LLM response
- Convert "falls_back" tests to pytest.raises(_LLMPlannerFailure)
- Mark Step 12 closure in spec/refactor_report_outline.md and prune
  ~170 lines of obsolete Step 8/9 implementation detail

Co-Authored-By: Claude Opus 4.7 (1M context) <noreply@anthropic.com>
</commit_message>
<xml_diff>
--- a/tests/fixtures/report_baseline/normal/golden.pptx
+++ b/tests/fixtures/report_baseline/normal/golden.pptx
@@ -16,7 +16,6 @@
     <p:sldId id="264" r:id="rId15"/>
     <p:sldId id="265" r:id="rId16"/>
     <p:sldId id="266" r:id="rId17"/>
-    <p:sldId id="267" r:id="rId18"/>
   </p:sldIdLst>
   <p:sldSz cx="9144000" cy="6858000" type="screen4x3"/>
   <p:notesSz cx="6858000" cy="9144000"/>
@@ -3367,14 +3366,6 @@
 <file path=ppt/slides/slide11.xml><?xml version="1.0" encoding="utf-8"?>
 <p:sld xmlns:a="http://schemas.openxmlformats.org/drawingml/2006/main" xmlns:p="http://schemas.openxmlformats.org/presentationml/2006/main" xmlns:r="http://schemas.openxmlformats.org/officeDocument/2006/relationships">
   <p:cSld>
-    <p:bg>
-      <p:bgPr>
-        <a:solidFill>
-          <a:srgbClr val="1E3A5F"/>
-        </a:solidFill>
-        <a:effectLst/>
-      </p:bgPr>
-    </p:bg>
     <p:spTree>
       <p:nvGrpSpPr>
         <p:cNvPr id="1" name=""/>
@@ -3384,50 +3375,14 @@
       <p:grpSpPr/>
       <p:sp>
         <p:nvSpPr>
-          <p:cNvPr id="2" name="TextBox 1"/>
-          <p:cNvSpPr txBox="1"/>
-          <p:nvPr/>
-        </p:nvSpPr>
-        <p:spPr>
-          <a:xfrm>
-            <a:off x="457200" y="274320"/>
-            <a:ext cx="8229600" cy="731520"/>
-          </a:xfrm>
-          <a:prstGeom prst="rect">
-            <a:avLst/>
-          </a:prstGeom>
-          <a:noFill/>
-        </p:spPr>
-        <p:txBody>
-          <a:bodyPr wrap="square">
-            <a:spAutoFit/>
-          </a:bodyPr>
-          <a:lstStyle/>
-          <a:p>
-            <a:pPr algn="ctr">
-              <a:defRPr sz="2400" b="1">
-                <a:solidFill>
-                  <a:srgbClr val="FFFFFF"/>
-                </a:solidFill>
-                <a:latin typeface="Microsoft YaHei"/>
-              </a:defRPr>
-            </a:pPr>
-            <a:r>
-              <a:t>核心结论与建议</a:t>
-            </a:r>
-          </a:p>
-        </p:txBody>
-      </p:sp>
-      <p:sp>
-        <p:nvSpPr>
-          <p:cNvPr id="3" name="Rectangle 2"/>
+          <p:cNvPr id="2" name="Rectangle 1"/>
           <p:cNvSpPr/>
           <p:nvPr/>
         </p:nvSpPr>
         <p:spPr>
           <a:xfrm>
-            <a:off x="3200400" y="1005840"/>
-            <a:ext cx="2743200" cy="54864"/>
+            <a:off x="274320" y="274320"/>
+            <a:ext cx="73152" cy="6309360"/>
           </a:xfrm>
           <a:prstGeom prst="rect">
             <a:avLst/>
@@ -3463,14 +3418,14 @@
       </p:sp>
       <p:sp>
         <p:nvSpPr>
-          <p:cNvPr id="4" name="TextBox 3"/>
+          <p:cNvPr id="3" name="TextBox 2"/>
           <p:cNvSpPr txBox="1"/>
           <p:nvPr/>
         </p:nvSpPr>
         <p:spPr>
           <a:xfrm>
-            <a:off x="914400" y="1371600"/>
-            <a:ext cx="7315200" cy="731520"/>
+            <a:off x="548640" y="274320"/>
+            <a:ext cx="8229600" cy="731520"/>
           </a:xfrm>
           <a:prstGeom prst="rect">
             <a:avLst/>
@@ -3484,55 +3439,29 @@
           <a:lstStyle/>
           <a:p>
             <a:pPr algn="l">
-              <a:defRPr sz="1400" b="0">
+              <a:defRPr sz="1800" b="1">
                 <a:solidFill>
-                  <a:srgbClr val="FFFFFF"/>
+                  <a:srgbClr val="1E3A5F"/>
                 </a:solidFill>
                 <a:latin typeface="Microsoft YaHei"/>
               </a:defRPr>
             </a:pPr>
             <a:r>
-              <a:t>  三港区集装箱吞吐量整体稳健增长，大连港持续领跑。</a:t>
-            </a:r>
-          </a:p>
-        </p:txBody>
-      </p:sp>
-    </p:spTree>
-  </p:cSld>
-  <p:clrMapOvr>
-    <a:masterClrMapping/>
-  </p:clrMapOvr>
-</p:sld>
-</file>
-
-<file path=ppt/slides/slide12.xml><?xml version="1.0" encoding="utf-8"?>
-<p:sld xmlns:a="http://schemas.openxmlformats.org/drawingml/2006/main" xmlns:p="http://schemas.openxmlformats.org/presentationml/2006/main" xmlns:r="http://schemas.openxmlformats.org/officeDocument/2006/relationships">
-  <p:cSld>
-    <p:bg>
-      <p:bgPr>
-        <a:solidFill>
-          <a:srgbClr val="1E3A5F"/>
-        </a:solidFill>
-        <a:effectLst/>
-      </p:bgPr>
-    </p:bg>
-    <p:spTree>
-      <p:nvGrpSpPr>
-        <p:cNvPr id="1" name=""/>
-        <p:cNvGrpSpPr/>
-        <p:nvPr/>
-      </p:nvGrpSpPr>
-      <p:grpSpPr/>
-      <p:sp>
-        <p:nvSpPr>
-          <p:cNvPr id="2" name="TextBox 1"/>
+              <a:t>三、综合结论</a:t>
+            </a:r>
+          </a:p>
+        </p:txBody>
+      </p:sp>
+      <p:sp>
+        <p:nvSpPr>
+          <p:cNvPr id="4" name="TextBox 3"/>
           <p:cNvSpPr txBox="1"/>
           <p:nvPr/>
         </p:nvSpPr>
         <p:spPr>
           <a:xfrm>
-            <a:off x="914400" y="2286000"/>
-            <a:ext cx="7315200" cy="1371600"/>
+            <a:off x="731520" y="1188720"/>
+            <a:ext cx="7863840" cy="5303520"/>
           </a:xfrm>
           <a:prstGeom prst="rect">
             <a:avLst/>
@@ -3545,95 +3474,19 @@
           </a:bodyPr>
           <a:lstStyle/>
           <a:p>
-            <a:pPr algn="ctr">
-              <a:defRPr sz="2800" b="1">
+            <a:pPr>
+              <a:spcBef>
+                <a:spcPts val="600"/>
+              </a:spcBef>
+              <a:defRPr sz="1400">
                 <a:solidFill>
-                  <a:srgbClr val="FFFFFF"/>
+                  <a:srgbClr val="333333"/>
                 </a:solidFill>
                 <a:latin typeface="Microsoft YaHei"/>
               </a:defRPr>
             </a:pPr>
             <a:r>
-              <a:t>谢谢观看</a:t>
-            </a:r>
-          </a:p>
-        </p:txBody>
-      </p:sp>
-      <p:sp>
-        <p:nvSpPr>
-          <p:cNvPr id="3" name="Rectangle 2"/>
-          <p:cNvSpPr/>
-          <p:nvPr/>
-        </p:nvSpPr>
-        <p:spPr>
-          <a:xfrm>
-            <a:off x="3657600" y="3657600"/>
-            <a:ext cx="1828800" cy="54864"/>
-          </a:xfrm>
-          <a:prstGeom prst="rect">
-            <a:avLst/>
-          </a:prstGeom>
-          <a:solidFill>
-            <a:srgbClr val="F0A500"/>
-          </a:solidFill>
-          <a:ln>
-            <a:noFill/>
-          </a:ln>
-        </p:spPr>
-        <p:style>
-          <a:lnRef idx="1">
-            <a:schemeClr val="accent1"/>
-          </a:lnRef>
-          <a:fillRef idx="3">
-            <a:schemeClr val="accent1"/>
-          </a:fillRef>
-          <a:effectRef idx="2">
-            <a:schemeClr val="accent1"/>
-          </a:effectRef>
-          <a:fontRef idx="minor">
-            <a:schemeClr val="lt1"/>
-          </a:fontRef>
-        </p:style>
-        <p:txBody>
-          <a:bodyPr rtlCol="0" anchor="ctr"/>
-          <a:lstStyle/>
-          <a:p>
-            <a:pPr algn="ctr"/>
-          </a:p>
-        </p:txBody>
-      </p:sp>
-      <p:sp>
-        <p:nvSpPr>
-          <p:cNvPr id="4" name="TextBox 3"/>
-          <p:cNvSpPr txBox="1"/>
-          <p:nvPr/>
-        </p:nvSpPr>
-        <p:spPr>
-          <a:xfrm>
-            <a:off x="914400" y="4114800"/>
-            <a:ext cx="7315200" cy="914400"/>
-          </a:xfrm>
-          <a:prstGeom prst="rect">
-            <a:avLst/>
-          </a:prstGeom>
-          <a:noFill/>
-        </p:spPr>
-        <p:txBody>
-          <a:bodyPr wrap="square">
-            <a:spAutoFit/>
-          </a:bodyPr>
-          <a:lstStyle/>
-          <a:p>
-            <a:pPr algn="ctr">
-              <a:defRPr sz="1800" b="0">
-                <a:solidFill>
-                  <a:srgbClr val="F0A500"/>
-                </a:solidFill>
-                <a:latin typeface="Calibri"/>
-              </a:defRPr>
-            </a:pPr>
-            <a:r>
-              <a:t>THANK YOU</a:t>
+              <a:t>三港区集装箱吞吐量整体稳健增长，大连港持续领跑。</a:t>
             </a:r>
           </a:p>
         </p:txBody>
@@ -4508,6 +4361,142 @@
 </file>
 
 <file path=ppt/slides/slide5.xml><?xml version="1.0" encoding="utf-8"?>
+<p:sld xmlns:a="http://schemas.openxmlformats.org/drawingml/2006/main" xmlns:p="http://schemas.openxmlformats.org/presentationml/2006/main" xmlns:r="http://schemas.openxmlformats.org/officeDocument/2006/relationships">
+  <p:cSld>
+    <p:spTree>
+      <p:nvGrpSpPr>
+        <p:cNvPr id="1" name=""/>
+        <p:cNvGrpSpPr/>
+        <p:nvPr/>
+      </p:nvGrpSpPr>
+      <p:grpSpPr/>
+      <p:sp>
+        <p:nvSpPr>
+          <p:cNvPr id="2" name="Rectangle 1"/>
+          <p:cNvSpPr/>
+          <p:nvPr/>
+        </p:nvSpPr>
+        <p:spPr>
+          <a:xfrm>
+            <a:off x="274320" y="274320"/>
+            <a:ext cx="73152" cy="6309360"/>
+          </a:xfrm>
+          <a:prstGeom prst="rect">
+            <a:avLst/>
+          </a:prstGeom>
+          <a:solidFill>
+            <a:srgbClr val="F0A500"/>
+          </a:solidFill>
+          <a:ln>
+            <a:noFill/>
+          </a:ln>
+        </p:spPr>
+        <p:style>
+          <a:lnRef idx="1">
+            <a:schemeClr val="accent1"/>
+          </a:lnRef>
+          <a:fillRef idx="3">
+            <a:schemeClr val="accent1"/>
+          </a:fillRef>
+          <a:effectRef idx="2">
+            <a:schemeClr val="accent1"/>
+          </a:effectRef>
+          <a:fontRef idx="minor">
+            <a:schemeClr val="lt1"/>
+          </a:fontRef>
+        </p:style>
+        <p:txBody>
+          <a:bodyPr rtlCol="0" anchor="ctr"/>
+          <a:lstStyle/>
+          <a:p>
+            <a:pPr algn="ctr"/>
+          </a:p>
+        </p:txBody>
+      </p:sp>
+      <p:sp>
+        <p:nvSpPr>
+          <p:cNvPr id="3" name="TextBox 2"/>
+          <p:cNvSpPr txBox="1"/>
+          <p:nvPr/>
+        </p:nvSpPr>
+        <p:spPr>
+          <a:xfrm>
+            <a:off x="548640" y="274320"/>
+            <a:ext cx="8229600" cy="731520"/>
+          </a:xfrm>
+          <a:prstGeom prst="rect">
+            <a:avLst/>
+          </a:prstGeom>
+          <a:noFill/>
+        </p:spPr>
+        <p:txBody>
+          <a:bodyPr wrap="square">
+            <a:spAutoFit/>
+          </a:bodyPr>
+          <a:lstStyle/>
+          <a:p>
+            <a:pPr algn="l">
+              <a:defRPr sz="1800" b="1">
+                <a:solidFill>
+                  <a:srgbClr val="1E3A5F"/>
+                </a:solidFill>
+                <a:latin typeface="Microsoft YaHei"/>
+              </a:defRPr>
+            </a:pPr>
+            <a:r>
+              <a:t>一、港区吞吐量现状</a:t>
+            </a:r>
+          </a:p>
+        </p:txBody>
+      </p:sp>
+      <p:sp>
+        <p:nvSpPr>
+          <p:cNvPr id="4" name="TextBox 3"/>
+          <p:cNvSpPr txBox="1"/>
+          <p:nvPr/>
+        </p:nvSpPr>
+        <p:spPr>
+          <a:xfrm>
+            <a:off x="731520" y="1188720"/>
+            <a:ext cx="7863840" cy="5303520"/>
+          </a:xfrm>
+          <a:prstGeom prst="rect">
+            <a:avLst/>
+          </a:prstGeom>
+          <a:noFill/>
+        </p:spPr>
+        <p:txBody>
+          <a:bodyPr wrap="square">
+            <a:spAutoFit/>
+          </a:bodyPr>
+          <a:lstStyle/>
+          <a:p>
+            <a:pPr>
+              <a:spcBef>
+                <a:spcPts val="600"/>
+              </a:spcBef>
+              <a:defRPr sz="1400">
+                <a:solidFill>
+                  <a:srgbClr val="333333"/>
+                </a:solidFill>
+                <a:latin typeface="Microsoft YaHei"/>
+              </a:defRPr>
+            </a:pPr>
+            <a:r>
+              <a:t>2026 Q1 大连港吞吐量达 4500.5 万吨，同比增长 12%，居三港之首；营口港 3200.1 万吨，锦州港 1800.0 万吨。</a:t>
+            </a:r>
+          </a:p>
+        </p:txBody>
+      </p:sp>
+    </p:spTree>
+  </p:cSld>
+  <p:clrMapOvr>
+    <a:masterClrMapping/>
+  </p:clrMapOvr>
+</p:sld>
+</file>
+
+<file path=ppt/slides/slide6.xml><?xml version="1.0" encoding="utf-8"?>
 <p:sld xmlns:a="http://schemas.openxmlformats.org/drawingml/2006/main" xmlns:p="http://schemas.openxmlformats.org/presentationml/2006/main" xmlns:r="http://schemas.openxmlformats.org/officeDocument/2006/relationships">
   <p:cSld>
     <p:spTree>
@@ -4751,7 +4740,7 @@
 </p:sld>
 </file>
 
-<file path=ppt/slides/slide6.xml><?xml version="1.0" encoding="utf-8"?>
+<file path=ppt/slides/slide7.xml><?xml version="1.0" encoding="utf-8"?>
 <p:sld xmlns:a="http://schemas.openxmlformats.org/drawingml/2006/main" xmlns:p="http://schemas.openxmlformats.org/presentationml/2006/main" xmlns:r="http://schemas.openxmlformats.org/officeDocument/2006/relationships">
   <p:cSld>
     <p:bg>
@@ -4881,283 +4870,6 @@
           <a:lstStyle/>
           <a:p>
             <a:pPr algn="ctr"/>
-          </a:p>
-        </p:txBody>
-      </p:sp>
-    </p:spTree>
-  </p:cSld>
-  <p:clrMapOvr>
-    <a:masterClrMapping/>
-  </p:clrMapOvr>
-</p:sld>
-</file>
-
-<file path=ppt/slides/slide7.xml><?xml version="1.0" encoding="utf-8"?>
-<p:sld xmlns:a="http://schemas.openxmlformats.org/drawingml/2006/main" xmlns:p="http://schemas.openxmlformats.org/presentationml/2006/main" xmlns:r="http://schemas.openxmlformats.org/officeDocument/2006/relationships">
-  <p:cSld>
-    <p:spTree>
-      <p:nvGrpSpPr>
-        <p:cNvPr id="1" name=""/>
-        <p:cNvGrpSpPr/>
-        <p:nvPr/>
-      </p:nvGrpSpPr>
-      <p:grpSpPr/>
-      <p:sp>
-        <p:nvSpPr>
-          <p:cNvPr id="2" name="TextBox 1"/>
-          <p:cNvSpPr txBox="1"/>
-          <p:nvPr/>
-        </p:nvSpPr>
-        <p:spPr>
-          <a:xfrm>
-            <a:off x="457200" y="274320"/>
-            <a:ext cx="8229600" cy="731520"/>
-          </a:xfrm>
-          <a:prstGeom prst="rect">
-            <a:avLst/>
-          </a:prstGeom>
-          <a:noFill/>
-        </p:spPr>
-        <p:txBody>
-          <a:bodyPr wrap="square">
-            <a:spAutoFit/>
-          </a:bodyPr>
-          <a:lstStyle/>
-          <a:p>
-            <a:pPr algn="ctr">
-              <a:defRPr sz="1800" b="1">
-                <a:solidFill>
-                  <a:srgbClr val="1E3A5F"/>
-                </a:solidFill>
-                <a:latin typeface="Microsoft YaHei"/>
-              </a:defRPr>
-            </a:pPr>
-            <a:r>
-              <a:t>二、关键指标分析</a:t>
-            </a:r>
-          </a:p>
-        </p:txBody>
-      </p:sp>
-      <p:sp>
-        <p:nvSpPr>
-          <p:cNvPr id="3" name="Rectangle 2"/>
-          <p:cNvSpPr/>
-          <p:nvPr/>
-        </p:nvSpPr>
-        <p:spPr>
-          <a:xfrm>
-            <a:off x="1051560" y="1463040"/>
-            <a:ext cx="7040880" cy="4114800"/>
-          </a:xfrm>
-          <a:prstGeom prst="rect">
-            <a:avLst/>
-          </a:prstGeom>
-          <a:solidFill>
-            <a:srgbClr val="F5F7FA"/>
-          </a:solidFill>
-          <a:ln>
-            <a:noFill/>
-          </a:ln>
-        </p:spPr>
-        <p:style>
-          <a:lnRef idx="1">
-            <a:schemeClr val="accent1"/>
-          </a:lnRef>
-          <a:fillRef idx="3">
-            <a:schemeClr val="accent1"/>
-          </a:fillRef>
-          <a:effectRef idx="2">
-            <a:schemeClr val="accent1"/>
-          </a:effectRef>
-          <a:fontRef idx="minor">
-            <a:schemeClr val="lt1"/>
-          </a:fontRef>
-        </p:style>
-        <p:txBody>
-          <a:bodyPr rtlCol="0" anchor="ctr"/>
-          <a:lstStyle/>
-          <a:p>
-            <a:pPr algn="ctr"/>
-          </a:p>
-        </p:txBody>
-      </p:sp>
-      <p:sp>
-        <p:nvSpPr>
-          <p:cNvPr id="4" name="TextBox 3"/>
-          <p:cNvSpPr txBox="1"/>
-          <p:nvPr/>
-        </p:nvSpPr>
-        <p:spPr>
-          <a:xfrm>
-            <a:off x="1188720" y="1645920"/>
-            <a:ext cx="6766560" cy="548640"/>
-          </a:xfrm>
-          <a:prstGeom prst="rect">
-            <a:avLst/>
-          </a:prstGeom>
-          <a:noFill/>
-        </p:spPr>
-        <p:txBody>
-          <a:bodyPr wrap="square">
-            <a:spAutoFit/>
-          </a:bodyPr>
-          <a:lstStyle/>
-          <a:p>
-            <a:pPr algn="ctr">
-              <a:defRPr sz="1100" b="1">
-                <a:solidFill>
-                  <a:srgbClr val="546E7A"/>
-                </a:solidFill>
-                <a:latin typeface="Microsoft YaHei"/>
-              </a:defRPr>
-            </a:pPr>
-            <a:r>
-              <a:t>throughput</a:t>
-            </a:r>
-          </a:p>
-        </p:txBody>
-      </p:sp>
-      <p:sp>
-        <p:nvSpPr>
-          <p:cNvPr id="5" name="TextBox 4"/>
-          <p:cNvSpPr txBox="1"/>
-          <p:nvPr/>
-        </p:nvSpPr>
-        <p:spPr>
-          <a:xfrm>
-            <a:off x="1188720" y="2377440"/>
-            <a:ext cx="6766560" cy="1097280"/>
-          </a:xfrm>
-          <a:prstGeom prst="rect">
-            <a:avLst/>
-          </a:prstGeom>
-          <a:noFill/>
-        </p:spPr>
-        <p:txBody>
-          <a:bodyPr wrap="square">
-            <a:spAutoFit/>
-          </a:bodyPr>
-          <a:lstStyle/>
-          <a:p>
-            <a:pPr algn="ctr">
-              <a:defRPr sz="3600" b="1">
-                <a:solidFill>
-                  <a:srgbClr val="2E7D32"/>
-                </a:solidFill>
-                <a:latin typeface="Calibri"/>
-              </a:defRPr>
-            </a:pPr>
-            <a:r>
-              <a:t>↑12.0%</a:t>
-            </a:r>
-          </a:p>
-        </p:txBody>
-      </p:sp>
-      <p:sp>
-        <p:nvSpPr>
-          <p:cNvPr id="6" name="TextBox 5"/>
-          <p:cNvSpPr txBox="1"/>
-          <p:nvPr/>
-        </p:nvSpPr>
-        <p:spPr>
-          <a:xfrm>
-            <a:off x="1188720" y="3474720"/>
-            <a:ext cx="6766560" cy="457200"/>
-          </a:xfrm>
-          <a:prstGeom prst="rect">
-            <a:avLst/>
-          </a:prstGeom>
-          <a:noFill/>
-        </p:spPr>
-        <p:txBody>
-          <a:bodyPr wrap="square">
-            <a:spAutoFit/>
-          </a:bodyPr>
-          <a:lstStyle/>
-          <a:p>
-            <a:pPr algn="ctr">
-              <a:defRPr sz="1100" b="0">
-                <a:solidFill>
-                  <a:srgbClr val="546E7A"/>
-                </a:solidFill>
-                <a:latin typeface="Microsoft YaHei"/>
-              </a:defRPr>
-            </a:pPr>
-            <a:r>
-              <a:t>同比</a:t>
-            </a:r>
-          </a:p>
-        </p:txBody>
-      </p:sp>
-      <p:sp>
-        <p:nvSpPr>
-          <p:cNvPr id="7" name="TextBox 6"/>
-          <p:cNvSpPr txBox="1"/>
-          <p:nvPr/>
-        </p:nvSpPr>
-        <p:spPr>
-          <a:xfrm>
-            <a:off x="1188720" y="4023360"/>
-            <a:ext cx="6766560" cy="914400"/>
-          </a:xfrm>
-          <a:prstGeom prst="rect">
-            <a:avLst/>
-          </a:prstGeom>
-          <a:noFill/>
-        </p:spPr>
-        <p:txBody>
-          <a:bodyPr wrap="square">
-            <a:spAutoFit/>
-          </a:bodyPr>
-          <a:lstStyle/>
-          <a:p>
-            <a:pPr algn="ctr">
-              <a:defRPr sz="2400" b="1">
-                <a:solidFill>
-                  <a:srgbClr val="2E7D32"/>
-                </a:solidFill>
-                <a:latin typeface="Calibri"/>
-              </a:defRPr>
-            </a:pPr>
-            <a:r>
-              <a:t>↑3.0%</a:t>
-            </a:r>
-          </a:p>
-        </p:txBody>
-      </p:sp>
-      <p:sp>
-        <p:nvSpPr>
-          <p:cNvPr id="8" name="TextBox 7"/>
-          <p:cNvSpPr txBox="1"/>
-          <p:nvPr/>
-        </p:nvSpPr>
-        <p:spPr>
-          <a:xfrm>
-            <a:off x="1188720" y="4937760"/>
-            <a:ext cx="6766560" cy="457200"/>
-          </a:xfrm>
-          <a:prstGeom prst="rect">
-            <a:avLst/>
-          </a:prstGeom>
-          <a:noFill/>
-        </p:spPr>
-        <p:txBody>
-          <a:bodyPr wrap="square">
-            <a:spAutoFit/>
-          </a:bodyPr>
-          <a:lstStyle/>
-          <a:p>
-            <a:pPr algn="ctr">
-              <a:defRPr sz="1100" b="0">
-                <a:solidFill>
-                  <a:srgbClr val="546E7A"/>
-                </a:solidFill>
-                <a:latin typeface="Microsoft YaHei"/>
-              </a:defRPr>
-            </a:pPr>
-            <a:r>
-              <a:t>环比</a:t>
-            </a:r>
           </a:p>
         </p:txBody>
       </p:sp>
@@ -5188,7 +4900,7 @@
         <p:spPr>
           <a:xfrm>
             <a:off x="457200" y="274320"/>
-            <a:ext cx="8229600" cy="640080"/>
+            <a:ext cx="8229600" cy="731520"/>
           </a:xfrm>
           <a:prstGeom prst="rect">
             <a:avLst/>
@@ -5201,7 +4913,7 @@
           </a:bodyPr>
           <a:lstStyle/>
           <a:p>
-            <a:pPr algn="l">
+            <a:pPr algn="ctr">
               <a:defRPr sz="1800" b="1">
                 <a:solidFill>
                   <a:srgbClr val="1E3A5F"/>
@@ -5223,14 +4935,14 @@
         </p:nvSpPr>
         <p:spPr>
           <a:xfrm>
-            <a:off x="4526280" y="1097280"/>
-            <a:ext cx="45720" cy="5303520"/>
+            <a:off x="1051560" y="1463040"/>
+            <a:ext cx="7040880" cy="4114800"/>
           </a:xfrm>
           <a:prstGeom prst="rect">
             <a:avLst/>
           </a:prstGeom>
           <a:solidFill>
-            <a:srgbClr val="F0A500"/>
+            <a:srgbClr val="F5F7FA"/>
           </a:solidFill>
           <a:ln>
             <a:noFill/>
@@ -5266,8 +4978,8 @@
         </p:nvSpPr>
         <p:spPr>
           <a:xfrm>
-            <a:off x="457200" y="1188720"/>
-            <a:ext cx="3931920" cy="5212080"/>
+            <a:off x="1188720" y="1645920"/>
+            <a:ext cx="6766560" cy="548640"/>
           </a:xfrm>
           <a:prstGeom prst="rect">
             <a:avLst/>
@@ -5280,19 +4992,16 @@
           </a:bodyPr>
           <a:lstStyle/>
           <a:p>
-            <a:pPr>
-              <a:spcBef>
-                <a:spcPts val="400"/>
-              </a:spcBef>
-              <a:defRPr sz="1300">
+            <a:pPr algn="ctr">
+              <a:defRPr sz="1100" b="1">
                 <a:solidFill>
-                  <a:srgbClr val="333333"/>
+                  <a:srgbClr val="546E7A"/>
                 </a:solidFill>
                 <a:latin typeface="Microsoft YaHei"/>
               </a:defRPr>
             </a:pPr>
             <a:r>
-              <a:t>2026 Q1 大连港吞吐量达 4500.5 万吨，同比增长 12%，居三港之首；营口港 3200.1 万吨，锦州港 1800.0 万吨。</a:t>
+              <a:t>throughput</a:t>
             </a:r>
           </a:p>
         </p:txBody>
@@ -5305,8 +5014,8 @@
         </p:nvSpPr>
         <p:spPr>
           <a:xfrm>
-            <a:off x="4754880" y="1188720"/>
-            <a:ext cx="3931920" cy="5212080"/>
+            <a:off x="1188720" y="2377440"/>
+            <a:ext cx="6766560" cy="1097280"/>
           </a:xfrm>
           <a:prstGeom prst="rect">
             <a:avLst/>
@@ -5319,19 +5028,124 @@
           </a:bodyPr>
           <a:lstStyle/>
           <a:p>
-            <a:pPr>
-              <a:spcBef>
-                <a:spcPts val="400"/>
-              </a:spcBef>
-              <a:defRPr sz="1300">
+            <a:pPr algn="ctr">
+              <a:defRPr sz="3600" b="1">
                 <a:solidFill>
-                  <a:srgbClr val="333333"/>
+                  <a:srgbClr val="2E7D32"/>
+                </a:solidFill>
+                <a:latin typeface="Calibri"/>
+              </a:defRPr>
+            </a:pPr>
+            <a:r>
+              <a:t>↑12.0%</a:t>
+            </a:r>
+          </a:p>
+        </p:txBody>
+      </p:sp>
+      <p:sp>
+        <p:nvSpPr>
+          <p:cNvPr id="6" name="TextBox 5"/>
+          <p:cNvSpPr txBox="1"/>
+          <p:nvPr/>
+        </p:nvSpPr>
+        <p:spPr>
+          <a:xfrm>
+            <a:off x="1188720" y="3474720"/>
+            <a:ext cx="6766560" cy="457200"/>
+          </a:xfrm>
+          <a:prstGeom prst="rect">
+            <a:avLst/>
+          </a:prstGeom>
+          <a:noFill/>
+        </p:spPr>
+        <p:txBody>
+          <a:bodyPr wrap="square">
+            <a:spAutoFit/>
+          </a:bodyPr>
+          <a:lstStyle/>
+          <a:p>
+            <a:pPr algn="ctr">
+              <a:defRPr sz="1100" b="0">
+                <a:solidFill>
+                  <a:srgbClr val="546E7A"/>
                 </a:solidFill>
                 <a:latin typeface="Microsoft YaHei"/>
               </a:defRPr>
             </a:pPr>
             <a:r>
-              <a:t>throughput：均值 3,166.87</a:t>
+              <a:t>同比</a:t>
+            </a:r>
+          </a:p>
+        </p:txBody>
+      </p:sp>
+      <p:sp>
+        <p:nvSpPr>
+          <p:cNvPr id="7" name="TextBox 6"/>
+          <p:cNvSpPr txBox="1"/>
+          <p:nvPr/>
+        </p:nvSpPr>
+        <p:spPr>
+          <a:xfrm>
+            <a:off x="1188720" y="4023360"/>
+            <a:ext cx="6766560" cy="914400"/>
+          </a:xfrm>
+          <a:prstGeom prst="rect">
+            <a:avLst/>
+          </a:prstGeom>
+          <a:noFill/>
+        </p:spPr>
+        <p:txBody>
+          <a:bodyPr wrap="square">
+            <a:spAutoFit/>
+          </a:bodyPr>
+          <a:lstStyle/>
+          <a:p>
+            <a:pPr algn="ctr">
+              <a:defRPr sz="2400" b="1">
+                <a:solidFill>
+                  <a:srgbClr val="2E7D32"/>
+                </a:solidFill>
+                <a:latin typeface="Calibri"/>
+              </a:defRPr>
+            </a:pPr>
+            <a:r>
+              <a:t>↑3.0%</a:t>
+            </a:r>
+          </a:p>
+        </p:txBody>
+      </p:sp>
+      <p:sp>
+        <p:nvSpPr>
+          <p:cNvPr id="8" name="TextBox 7"/>
+          <p:cNvSpPr txBox="1"/>
+          <p:nvPr/>
+        </p:nvSpPr>
+        <p:spPr>
+          <a:xfrm>
+            <a:off x="1188720" y="4937760"/>
+            <a:ext cx="6766560" cy="457200"/>
+          </a:xfrm>
+          <a:prstGeom prst="rect">
+            <a:avLst/>
+          </a:prstGeom>
+          <a:noFill/>
+        </p:spPr>
+        <p:txBody>
+          <a:bodyPr wrap="square">
+            <a:spAutoFit/>
+          </a:bodyPr>
+          <a:lstStyle/>
+          <a:p>
+            <a:pPr algn="ctr">
+              <a:defRPr sz="1100" b="0">
+                <a:solidFill>
+                  <a:srgbClr val="546E7A"/>
+                </a:solidFill>
+                <a:latin typeface="Microsoft YaHei"/>
+              </a:defRPr>
+            </a:pPr>
+            <a:r>
+              <a:t>环比</a:t>
             </a:r>
           </a:p>
         </p:txBody>

</xml_diff>